<commit_message>
Week 8 L1 slide 4 notes + handouts: why the Bayer pattern has two greens
Co-Authored-By: Claude Opus 5.5 <noreply@anthropic.com>
</commit_message>
<xml_diff>
--- a/第八週(10-29)/第八週_第1節_簡報.pptx
+++ b/第八週(10-29)/第八週_第1節_簡報.pptx
@@ -4492,11 +4492,11 @@
                 <a:spcPts val="0"/>
               </a:spcBef>
               <a:spcAft>
-                <a:spcPts val="192"/>
+                <a:spcPts val="167"/>
               </a:spcAft>
             </a:pPr>
             <a:r>
-              <a:rPr sz="1150" b="1" lang="zh-TW" dirty="0">
+              <a:rPr sz="1000" b="1" lang="zh-TW" dirty="0">
                 <a:solidFill>
                   <a:srgbClr val="000000"/>
                 </a:solidFill>
@@ -4507,7 +4507,7 @@
               <a:t>這一張的目的：</a:t>
             </a:r>
             <a:r>
-              <a:rPr sz="1150" lang="zh-TW" dirty="0">
+              <a:rPr sz="1000" lang="zh-TW" dirty="0">
                 <a:solidFill>
                   <a:srgbClr val="000000"/>
                 </a:solidFill>
@@ -4525,11 +4525,11 @@
                 <a:spcPts val="0"/>
               </a:spcBef>
               <a:spcAft>
-                <a:spcPts val="192"/>
+                <a:spcPts val="167"/>
               </a:spcAft>
             </a:pPr>
             <a:r>
-              <a:rPr sz="1150" lang="zh-TW" dirty="0">
+              <a:rPr sz="1000" lang="zh-TW" dirty="0">
                 <a:solidFill>
                   <a:srgbClr val="000000"/>
                 </a:solidFill>
@@ -4547,11 +4547,11 @@
                 <a:spcPts val="0"/>
               </a:spcBef>
               <a:spcAft>
-                <a:spcPts val="192"/>
+                <a:spcPts val="167"/>
               </a:spcAft>
             </a:pPr>
             <a:r>
-              <a:rPr sz="1150" lang="zh-TW" dirty="0">
+              <a:rPr sz="1000" lang="zh-TW" dirty="0">
                 <a:solidFill>
                   <a:srgbClr val="000000"/>
                 </a:solidFill>
@@ -4562,7 +4562,7 @@
               <a:t>相機裡面有一塊</a:t>
             </a:r>
             <a:r>
-              <a:rPr sz="1150" b="1" lang="zh-TW" dirty="0">
+              <a:rPr sz="1000" b="1" lang="zh-TW" dirty="0">
                 <a:solidFill>
                   <a:srgbClr val="000000"/>
                 </a:solidFill>
@@ -4573,7 +4573,7 @@
               <a:t>影像感測器</a:t>
             </a:r>
             <a:r>
-              <a:rPr sz="1150" lang="zh-TW" dirty="0">
+              <a:rPr sz="1000" lang="zh-TW" dirty="0">
                 <a:solidFill>
                   <a:srgbClr val="000000"/>
                 </a:solidFill>
@@ -4584,7 +4584,7 @@
               <a:t>，第五週讀過它的規格表。nuScenes 用的是 1/1.8 吋的 CMOS 感測器，照片是 1600 乘 900 個像素。可以把它想成</a:t>
             </a:r>
             <a:r>
-              <a:rPr sz="1150" b="1" lang="zh-TW" dirty="0">
+              <a:rPr sz="1000" b="1" lang="zh-TW" dirty="0">
                 <a:solidFill>
                   <a:srgbClr val="000000"/>
                 </a:solidFill>
@@ -4595,7 +4595,7 @@
               <a:t>一大片排得整整齊齊的小水桶</a:t>
             </a:r>
             <a:r>
-              <a:rPr sz="1150" lang="zh-TW" dirty="0">
+              <a:rPr sz="1000" lang="zh-TW" dirty="0">
                 <a:solidFill>
                   <a:srgbClr val="000000"/>
                 </a:solidFill>
@@ -4613,11 +4613,11 @@
                 <a:spcPts val="0"/>
               </a:spcBef>
               <a:spcAft>
-                <a:spcPts val="192"/>
+                <a:spcPts val="167"/>
               </a:spcAft>
             </a:pPr>
             <a:r>
-              <a:rPr sz="1150" lang="zh-TW" dirty="0">
+              <a:rPr sz="1000" lang="zh-TW" dirty="0">
                 <a:solidFill>
                   <a:srgbClr val="000000"/>
                 </a:solidFill>
@@ -4628,7 +4628,7 @@
               <a:t>按下快門，也就是</a:t>
             </a:r>
             <a:r>
-              <a:rPr sz="1150" b="1" lang="zh-TW" dirty="0">
+              <a:rPr sz="1000" b="1" lang="zh-TW" dirty="0">
                 <a:solidFill>
                   <a:srgbClr val="000000"/>
                 </a:solidFill>
@@ -4639,7 +4639,7 @@
               <a:t>曝光</a:t>
             </a:r>
             <a:r>
-              <a:rPr sz="1150" lang="zh-TW" dirty="0">
+              <a:rPr sz="1000" lang="zh-TW" dirty="0">
                 <a:solidFill>
                   <a:srgbClr val="000000"/>
                 </a:solidFill>
@@ -4650,7 +4650,7 @@
               <a:t>的那一小段時間，光照進來，就像下雨，每個小水桶接光。光愈多，桶子裡接到的電就愈多；曝光結束，晶片把每一桶的電量</a:t>
             </a:r>
             <a:r>
-              <a:rPr sz="1150" b="1" lang="zh-TW" dirty="0">
+              <a:rPr sz="1000" b="1" lang="zh-TW" dirty="0">
                 <a:solidFill>
                   <a:srgbClr val="000000"/>
                 </a:solidFill>
@@ -4661,7 +4661,7 @@
               <a:t>換算成一個數字</a:t>
             </a:r>
             <a:r>
-              <a:rPr sz="1150" lang="zh-TW" dirty="0">
+              <a:rPr sz="1000" lang="zh-TW" dirty="0">
                 <a:solidFill>
                   <a:srgbClr val="000000"/>
                 </a:solidFill>
@@ -4679,11 +4679,11 @@
                 <a:spcPts val="0"/>
               </a:spcBef>
               <a:spcAft>
-                <a:spcPts val="192"/>
+                <a:spcPts val="167"/>
               </a:spcAft>
             </a:pPr>
             <a:r>
-              <a:rPr sz="1150" lang="zh-TW" dirty="0">
+              <a:rPr sz="1000" lang="zh-TW" dirty="0">
                 <a:solidFill>
                   <a:srgbClr val="000000"/>
                 </a:solidFill>
@@ -4694,7 +4694,7 @@
               <a:t>可是請注意，小水桶</a:t>
             </a:r>
             <a:r>
-              <a:rPr sz="1150" b="1" lang="zh-TW" dirty="0">
+              <a:rPr sz="1000" b="1" lang="zh-TW" dirty="0">
                 <a:solidFill>
                   <a:srgbClr val="000000"/>
                 </a:solidFill>
@@ -4705,7 +4705,7 @@
               <a:t>只分得出接到多少光，分不出是什麼顏色</a:t>
             </a:r>
             <a:r>
-              <a:rPr sz="1150" lang="zh-TW" dirty="0">
+              <a:rPr sz="1000" lang="zh-TW" dirty="0">
                 <a:solidFill>
                   <a:srgbClr val="000000"/>
                 </a:solidFill>
@@ -4723,11 +4723,11 @@
                 <a:spcPts val="0"/>
               </a:spcBef>
               <a:spcAft>
-                <a:spcPts val="192"/>
+                <a:spcPts val="167"/>
               </a:spcAft>
             </a:pPr>
             <a:r>
-              <a:rPr sz="1150" lang="zh-TW" dirty="0">
+              <a:rPr sz="1000" lang="zh-TW" dirty="0">
                 <a:solidFill>
                   <a:srgbClr val="000000"/>
                 </a:solidFill>
@@ -4738,7 +4738,7 @@
               <a:t>那顏色怎麼來？在每一個小水桶上面，</a:t>
             </a:r>
             <a:r>
-              <a:rPr sz="1150" b="1" lang="zh-TW" dirty="0">
+              <a:rPr sz="1000" b="1" lang="zh-TW" dirty="0">
                 <a:solidFill>
                   <a:srgbClr val="000000"/>
                 </a:solidFill>
@@ -4749,7 +4749,7 @@
               <a:t>貼一片很小的濾色片</a:t>
             </a:r>
             <a:r>
-              <a:rPr sz="1150" lang="zh-TW" dirty="0">
+              <a:rPr sz="1000" lang="zh-TW" dirty="0">
                 <a:solidFill>
                   <a:srgbClr val="000000"/>
                 </a:solidFill>
@@ -4760,7 +4760,7 @@
               <a:t>：紅的、綠的、藍的，排成固定的花樣，最常見的是兩乘兩一組，一個紅、兩個綠、一個藍。貼了紅色濾色片的那一格，就只量得到紅光有多少。這就是中間那一格：每個像素</a:t>
             </a:r>
             <a:r>
-              <a:rPr sz="1150" b="1" lang="zh-TW" dirty="0">
+              <a:rPr sz="1000" b="1" lang="zh-TW" dirty="0">
                 <a:solidFill>
                   <a:srgbClr val="000000"/>
                 </a:solidFill>
@@ -4771,7 +4771,7 @@
               <a:t>只有一種顏色的數字</a:t>
             </a:r>
             <a:r>
-              <a:rPr sz="1150" lang="zh-TW" dirty="0">
+              <a:rPr sz="1000" lang="zh-TW" dirty="0">
                 <a:solidFill>
                   <a:srgbClr val="000000"/>
                 </a:solidFill>
@@ -4789,41 +4789,85 @@
                 <a:spcPts val="0"/>
               </a:spcBef>
               <a:spcAft>
-                <a:spcPts val="192"/>
+                <a:spcPts val="167"/>
               </a:spcAft>
             </a:pPr>
             <a:r>
-              <a:rPr sz="1150" lang="zh-TW" dirty="0">
-                <a:solidFill>
-                  <a:srgbClr val="000000"/>
-                </a:solidFill>
-                <a:latin typeface="Arial Unicode MS"/>
-                <a:ea typeface="Arial Unicode MS"/>
-                <a:cs typeface="Arial Unicode MS"/>
-              </a:rPr>
-              <a:t>可是一個像素只量到一種顏色，另外兩種怎麼辦？相機的晶片會看旁邊的格子，把缺的兩個顏色</a:t>
-            </a:r>
-            <a:r>
-              <a:rPr sz="1150" b="1" lang="zh-TW" dirty="0">
-                <a:solidFill>
-                  <a:srgbClr val="000000"/>
-                </a:solidFill>
-                <a:latin typeface="Arial Unicode MS"/>
-                <a:ea typeface="Arial Unicode MS"/>
-                <a:cs typeface="Arial Unicode MS"/>
-              </a:rPr>
-              <a:t>估出來補上</a:t>
-            </a:r>
-            <a:r>
-              <a:rPr sz="1150" lang="zh-TW" dirty="0">
-                <a:solidFill>
-                  <a:srgbClr val="000000"/>
-                </a:solidFill>
-                <a:latin typeface="Arial Unicode MS"/>
-                <a:ea typeface="Arial Unicode MS"/>
-                <a:cs typeface="Arial Unicode MS"/>
-              </a:rPr>
-              <a:t>。補完，每個像素都有紅、綠、藍三個數字，就是右邊這一格，也就是上一張那六十四格。
+              <a:rPr sz="1000" lang="zh-TW" dirty="0">
+                <a:solidFill>
+                  <a:srgbClr val="000000"/>
+                </a:solidFill>
+                <a:latin typeface="Arial Unicode MS"/>
+                <a:ea typeface="Arial Unicode MS"/>
+                <a:cs typeface="Arial Unicode MS"/>
+              </a:rPr>
+              <a:t>為什麼綠色要兩個？因為</a:t>
+            </a:r>
+            <a:r>
+              <a:rPr sz="1000" b="1" lang="zh-TW" dirty="0">
+                <a:solidFill>
+                  <a:srgbClr val="000000"/>
+                </a:solidFill>
+                <a:latin typeface="Arial Unicode MS"/>
+                <a:ea typeface="Arial Unicode MS"/>
+                <a:cs typeface="Arial Unicode MS"/>
+              </a:rPr>
+              <a:t>人的眼睛對綠光最敏感</a:t>
+            </a:r>
+            <a:r>
+              <a:rPr sz="1000" lang="zh-TW" dirty="0">
+                <a:solidFill>
+                  <a:srgbClr val="000000"/>
+                </a:solidFill>
+                <a:latin typeface="Arial Unicode MS"/>
+                <a:ea typeface="Arial Unicode MS"/>
+                <a:cs typeface="Arial Unicode MS"/>
+              </a:rPr>
+              <a:t>，我們看到的「亮暗和細節」，大部分來自綠色。把一張彩色照片換成黑白時，常用的算法裡綠色就佔了將近六成（紅 0.30、綠 0.59、藍 0.11），左邊第一格就是這樣算的。所以多放一倍的綠，照片的</a:t>
+            </a:r>
+            <a:r>
+              <a:rPr sz="1000" b="1" lang="zh-TW" dirty="0">
+                <a:solidFill>
+                  <a:srgbClr val="000000"/>
+                </a:solidFill>
+                <a:latin typeface="Arial Unicode MS"/>
+                <a:ea typeface="Arial Unicode MS"/>
+                <a:cs typeface="Arial Unicode MS"/>
+              </a:rPr>
+              <a:t>清晰度</a:t>
+            </a:r>
+            <a:r>
+              <a:rPr sz="1000" lang="zh-TW" dirty="0">
+                <a:solidFill>
+                  <a:srgbClr val="000000"/>
+                </a:solidFill>
+                <a:latin typeface="Arial Unicode MS"/>
+                <a:ea typeface="Arial Unicode MS"/>
+                <a:cs typeface="Arial Unicode MS"/>
+              </a:rPr>
+              <a:t>比較好、雜訊比較少。代價是紅和藍各只佔四分之一，</a:t>
+            </a:r>
+            <a:r>
+              <a:rPr sz="1000" b="1" lang="zh-TW" dirty="0">
+                <a:solidFill>
+                  <a:srgbClr val="000000"/>
+                </a:solidFill>
+                <a:latin typeface="Arial Unicode MS"/>
+                <a:ea typeface="Arial Unicode MS"/>
+                <a:cs typeface="Arial Unicode MS"/>
+              </a:rPr>
+              <a:t>顏色的細節比較粗</a:t>
+            </a:r>
+            <a:r>
+              <a:rPr sz="1000" lang="zh-TW" dirty="0">
+                <a:solidFill>
+                  <a:srgbClr val="000000"/>
+                </a:solidFill>
+                <a:latin typeface="Arial Unicode MS"/>
+                <a:ea typeface="Arial Unicode MS"/>
+                <a:cs typeface="Arial Unicode MS"/>
+              </a:rPr>
+              <a:t>：很細的條紋邊緣可能出現假顏色；遠處很小的紅燈、煞車燈，落在上面的紅色格子比較少。車用相機有時會換成別的排列，例如把綠色換成不加濾色片的「透明格」，晚上收得到更多光，但顏色就分得沒那麼準。
 </a:t>
             </a:r>
           </a:p>
@@ -4833,63 +4877,41 @@
                 <a:spcPts val="0"/>
               </a:spcBef>
               <a:spcAft>
-                <a:spcPts val="192"/>
+                <a:spcPts val="167"/>
               </a:spcAft>
             </a:pPr>
             <a:r>
-              <a:rPr sz="1150" lang="zh-TW" dirty="0">
-                <a:solidFill>
-                  <a:srgbClr val="000000"/>
-                </a:solidFill>
-                <a:latin typeface="Arial Unicode MS"/>
-                <a:ea typeface="Arial Unicode MS"/>
-                <a:cs typeface="Arial Unicode MS"/>
-              </a:rPr>
-              <a:t>最後存成 JPEG 檔的時候，每種顏色用 </a:t>
-            </a:r>
-            <a:r>
-              <a:rPr sz="1150" b="1" lang="zh-TW" dirty="0">
-                <a:solidFill>
-                  <a:srgbClr val="000000"/>
-                </a:solidFill>
-                <a:latin typeface="Arial Unicode MS"/>
-                <a:ea typeface="Arial Unicode MS"/>
-                <a:cs typeface="Arial Unicode MS"/>
-              </a:rPr>
-              <a:t>8 個位元</a:t>
-            </a:r>
-            <a:r>
-              <a:rPr sz="1150" lang="zh-TW" dirty="0">
-                <a:solidFill>
-                  <a:srgbClr val="000000"/>
-                </a:solidFill>
-                <a:latin typeface="Arial Unicode MS"/>
-                <a:ea typeface="Arial Unicode MS"/>
-                <a:cs typeface="Arial Unicode MS"/>
-              </a:rPr>
-              <a:t>來記。8 個位元可以記 2 的 8 次方，256 種，所以數字是 </a:t>
-            </a:r>
-            <a:r>
-              <a:rPr sz="1150" b="1" lang="zh-TW" dirty="0">
-                <a:solidFill>
-                  <a:srgbClr val="000000"/>
-                </a:solidFill>
-                <a:latin typeface="Arial Unicode MS"/>
-                <a:ea typeface="Arial Unicode MS"/>
-                <a:cs typeface="Arial Unicode MS"/>
-              </a:rPr>
-              <a:t>0 到 255</a:t>
-            </a:r>
-            <a:r>
-              <a:rPr sz="1150" lang="zh-TW" dirty="0">
-                <a:solidFill>
-                  <a:srgbClr val="000000"/>
-                </a:solidFill>
-                <a:latin typeface="Arial Unicode MS"/>
-                <a:ea typeface="Arial Unicode MS"/>
-                <a:cs typeface="Arial Unicode MS"/>
-              </a:rPr>
-              <a:t>。
+              <a:rPr sz="1000" lang="zh-TW" dirty="0">
+                <a:solidFill>
+                  <a:srgbClr val="000000"/>
+                </a:solidFill>
+                <a:latin typeface="Arial Unicode MS"/>
+                <a:ea typeface="Arial Unicode MS"/>
+                <a:cs typeface="Arial Unicode MS"/>
+              </a:rPr>
+              <a:t>可是一個像素只量到一種顏色，另外兩種怎麼辦？相機的晶片會看旁邊的格子，把缺的兩個顏色</a:t>
+            </a:r>
+            <a:r>
+              <a:rPr sz="1000" b="1" lang="zh-TW" dirty="0">
+                <a:solidFill>
+                  <a:srgbClr val="000000"/>
+                </a:solidFill>
+                <a:latin typeface="Arial Unicode MS"/>
+                <a:ea typeface="Arial Unicode MS"/>
+                <a:cs typeface="Arial Unicode MS"/>
+              </a:rPr>
+              <a:t>估出來補上</a:t>
+            </a:r>
+            <a:r>
+              <a:rPr sz="1000" lang="zh-TW" dirty="0">
+                <a:solidFill>
+                  <a:srgbClr val="000000"/>
+                </a:solidFill>
+                <a:latin typeface="Arial Unicode MS"/>
+                <a:ea typeface="Arial Unicode MS"/>
+                <a:cs typeface="Arial Unicode MS"/>
+              </a:rPr>
+              <a:t>。補完，每個像素都有紅、綠、藍三個數字，就是右邊這一格，也就是上一張那六十四格。
 </a:t>
             </a:r>
           </a:p>
@@ -4899,63 +4921,63 @@
                 <a:spcPts val="0"/>
               </a:spcBef>
               <a:spcAft>
-                <a:spcPts val="192"/>
+                <a:spcPts val="167"/>
               </a:spcAft>
             </a:pPr>
             <a:r>
-              <a:rPr sz="1150" lang="zh-TW" dirty="0">
-                <a:solidFill>
-                  <a:srgbClr val="000000"/>
-                </a:solidFill>
-                <a:latin typeface="Arial Unicode MS"/>
-                <a:ea typeface="Arial Unicode MS"/>
-                <a:cs typeface="Arial Unicode MS"/>
-              </a:rPr>
-              <a:t>兩件事順便記一下。第一，nuScenes 的相機是</a:t>
-            </a:r>
-            <a:r>
-              <a:rPr sz="1150" b="1" lang="zh-TW" dirty="0">
-                <a:solidFill>
-                  <a:srgbClr val="000000"/>
-                </a:solidFill>
-                <a:latin typeface="Arial Unicode MS"/>
-                <a:ea typeface="Arial Unicode MS"/>
-                <a:cs typeface="Arial Unicode MS"/>
-              </a:rPr>
-              <a:t>自動曝光</a:t>
-            </a:r>
-            <a:r>
-              <a:rPr sz="1150" lang="zh-TW" dirty="0">
-                <a:solidFill>
-                  <a:srgbClr val="000000"/>
-                </a:solidFill>
-                <a:latin typeface="Arial Unicode MS"/>
-                <a:ea typeface="Arial Unicode MS"/>
-                <a:cs typeface="Arial Unicode MS"/>
-              </a:rPr>
-              <a:t>：太暗就讓水桶多接一點時間，太亮就少接一點。所以同一條白線，在不同照片裡數字不一定一樣。第二，桶子有大小，光太強就</a:t>
-            </a:r>
-            <a:r>
-              <a:rPr sz="1150" b="1" lang="zh-TW" dirty="0">
-                <a:solidFill>
-                  <a:srgbClr val="000000"/>
-                </a:solidFill>
-                <a:latin typeface="Arial Unicode MS"/>
-                <a:ea typeface="Arial Unicode MS"/>
-                <a:cs typeface="Arial Unicode MS"/>
-              </a:rPr>
-              <a:t>滿出來</a:t>
-            </a:r>
-            <a:r>
-              <a:rPr sz="1150" lang="zh-TW" dirty="0">
-                <a:solidFill>
-                  <a:srgbClr val="000000"/>
-                </a:solidFill>
-                <a:latin typeface="Arial Unicode MS"/>
-                <a:ea typeface="Arial Unicode MS"/>
-                <a:cs typeface="Arial Unicode MS"/>
-              </a:rPr>
-              <a:t>，數字頂到 255，那一塊就變成一片白，什麼細節都沒有了，這就是過曝。第五週講的「動態範圍」，就是一張照片裡，最亮和最暗能同時量得清楚的範圍。
+              <a:rPr sz="1000" lang="zh-TW" dirty="0">
+                <a:solidFill>
+                  <a:srgbClr val="000000"/>
+                </a:solidFill>
+                <a:latin typeface="Arial Unicode MS"/>
+                <a:ea typeface="Arial Unicode MS"/>
+                <a:cs typeface="Arial Unicode MS"/>
+              </a:rPr>
+              <a:t>最後存成 JPEG 檔的時候，每種顏色用 </a:t>
+            </a:r>
+            <a:r>
+              <a:rPr sz="1000" b="1" lang="zh-TW" dirty="0">
+                <a:solidFill>
+                  <a:srgbClr val="000000"/>
+                </a:solidFill>
+                <a:latin typeface="Arial Unicode MS"/>
+                <a:ea typeface="Arial Unicode MS"/>
+                <a:cs typeface="Arial Unicode MS"/>
+              </a:rPr>
+              <a:t>8 個位元</a:t>
+            </a:r>
+            <a:r>
+              <a:rPr sz="1000" lang="zh-TW" dirty="0">
+                <a:solidFill>
+                  <a:srgbClr val="000000"/>
+                </a:solidFill>
+                <a:latin typeface="Arial Unicode MS"/>
+                <a:ea typeface="Arial Unicode MS"/>
+                <a:cs typeface="Arial Unicode MS"/>
+              </a:rPr>
+              <a:t>來記。8 個位元可以記 2 的 8 次方，256 種，所以數字是 </a:t>
+            </a:r>
+            <a:r>
+              <a:rPr sz="1000" b="1" lang="zh-TW" dirty="0">
+                <a:solidFill>
+                  <a:srgbClr val="000000"/>
+                </a:solidFill>
+                <a:latin typeface="Arial Unicode MS"/>
+                <a:ea typeface="Arial Unicode MS"/>
+                <a:cs typeface="Arial Unicode MS"/>
+              </a:rPr>
+              <a:t>0 到 255</a:t>
+            </a:r>
+            <a:r>
+              <a:rPr sz="1000" lang="zh-TW" dirty="0">
+                <a:solidFill>
+                  <a:srgbClr val="000000"/>
+                </a:solidFill>
+                <a:latin typeface="Arial Unicode MS"/>
+                <a:ea typeface="Arial Unicode MS"/>
+                <a:cs typeface="Arial Unicode MS"/>
+              </a:rPr>
+              <a:t>。
 </a:t>
             </a:r>
           </a:p>
@@ -4965,11 +4987,77 @@
                 <a:spcPts val="0"/>
               </a:spcBef>
               <a:spcAft>
-                <a:spcPts val="192"/>
+                <a:spcPts val="167"/>
               </a:spcAft>
             </a:pPr>
             <a:r>
-              <a:rPr sz="1150" lang="zh-TW" dirty="0">
+              <a:rPr sz="1000" lang="zh-TW" dirty="0">
+                <a:solidFill>
+                  <a:srgbClr val="000000"/>
+                </a:solidFill>
+                <a:latin typeface="Arial Unicode MS"/>
+                <a:ea typeface="Arial Unicode MS"/>
+                <a:cs typeface="Arial Unicode MS"/>
+              </a:rPr>
+              <a:t>兩件事順便記一下。第一，nuScenes 的相機是</a:t>
+            </a:r>
+            <a:r>
+              <a:rPr sz="1000" b="1" lang="zh-TW" dirty="0">
+                <a:solidFill>
+                  <a:srgbClr val="000000"/>
+                </a:solidFill>
+                <a:latin typeface="Arial Unicode MS"/>
+                <a:ea typeface="Arial Unicode MS"/>
+                <a:cs typeface="Arial Unicode MS"/>
+              </a:rPr>
+              <a:t>自動曝光</a:t>
+            </a:r>
+            <a:r>
+              <a:rPr sz="1000" lang="zh-TW" dirty="0">
+                <a:solidFill>
+                  <a:srgbClr val="000000"/>
+                </a:solidFill>
+                <a:latin typeface="Arial Unicode MS"/>
+                <a:ea typeface="Arial Unicode MS"/>
+                <a:cs typeface="Arial Unicode MS"/>
+              </a:rPr>
+              <a:t>：太暗就讓水桶多接一點時間，太亮就少接一點。所以同一條白線，在不同照片裡數字不一定一樣。第二，桶子有大小，光太強就</a:t>
+            </a:r>
+            <a:r>
+              <a:rPr sz="1000" b="1" lang="zh-TW" dirty="0">
+                <a:solidFill>
+                  <a:srgbClr val="000000"/>
+                </a:solidFill>
+                <a:latin typeface="Arial Unicode MS"/>
+                <a:ea typeface="Arial Unicode MS"/>
+                <a:cs typeface="Arial Unicode MS"/>
+              </a:rPr>
+              <a:t>滿出來</a:t>
+            </a:r>
+            <a:r>
+              <a:rPr sz="1000" lang="zh-TW" dirty="0">
+                <a:solidFill>
+                  <a:srgbClr val="000000"/>
+                </a:solidFill>
+                <a:latin typeface="Arial Unicode MS"/>
+                <a:ea typeface="Arial Unicode MS"/>
+                <a:cs typeface="Arial Unicode MS"/>
+              </a:rPr>
+              <a:t>，數字頂到 255，那一塊就變成一片白，什麼細節都沒有了，這就是過曝。第五週講的「動態範圍」，就是一張照片裡，最亮和最暗能同時量得清楚的範圍。
+</a:t>
+            </a:r>
+          </a:p>
+          <a:p>
+            <a:pPr algn="l">
+              <a:spcBef>
+                <a:spcPts val="0"/>
+              </a:spcBef>
+              <a:spcAft>
+                <a:spcPts val="167"/>
+              </a:spcAft>
+            </a:pPr>
+            <a:r>
+              <a:rPr sz="1000" lang="zh-TW" dirty="0">
                 <a:solidFill>
                   <a:srgbClr val="000000"/>
                 </a:solidFill>

</xml_diff>

<commit_message>
Week 8 L1: introduce YOLOX where it is first named (slide 8); fix a stale image reference
Co-Authored-By: Claude Opus 5.5 <noreply@anthropic.com>
</commit_message>
<xml_diff>
--- a/第八週(10-29)/第八週_第1節_簡報.pptx
+++ b/第八週(10-29)/第八週_第1節_簡報.pptx
@@ -1944,11 +1944,11 @@
                 <a:spcPts val="0"/>
               </a:spcBef>
               <a:spcAft>
-                <a:spcPts val="267"/>
+                <a:spcPts val="250"/>
               </a:spcAft>
             </a:pPr>
             <a:r>
-              <a:rPr sz="1600" b="1" lang="zh-TW" dirty="0">
+              <a:rPr sz="1500" b="1" lang="zh-TW" dirty="0">
                 <a:solidFill>
                   <a:srgbClr val="000000"/>
                 </a:solidFill>
@@ -1959,7 +1959,7 @@
               <a:t>這一張的目的：</a:t>
             </a:r>
             <a:r>
-              <a:rPr sz="1600" lang="zh-TW" dirty="0">
+              <a:rPr sz="1500" lang="zh-TW" dirty="0">
                 <a:solidFill>
                   <a:srgbClr val="000000"/>
                 </a:solidFill>
@@ -1977,22 +1977,22 @@
                 <a:spcPts val="0"/>
               </a:spcBef>
               <a:spcAft>
-                <a:spcPts val="267"/>
+                <a:spcPts val="250"/>
               </a:spcAft>
             </a:pPr>
             <a:r>
-              <a:rPr sz="1600" lang="zh-TW" dirty="0">
-                <a:solidFill>
-                  <a:srgbClr val="000000"/>
-                </a:solidFill>
-                <a:latin typeface="Arial Unicode MS"/>
-                <a:ea typeface="Arial Unicode MS"/>
-                <a:cs typeface="Arial Unicode MS"/>
-              </a:rPr>
-              <a:t>把右邊那張放大來看。這種工作叫</a:t>
-            </a:r>
-            <a:r>
-              <a:rPr sz="1600" b="1" lang="zh-TW" dirty="0">
+              <a:rPr sz="1500" lang="zh-TW" dirty="0">
+                <a:solidFill>
+                  <a:srgbClr val="000000"/>
+                </a:solidFill>
+                <a:latin typeface="Arial Unicode MS"/>
+                <a:ea typeface="Arial Unicode MS"/>
+                <a:cs typeface="Arial Unicode MS"/>
+              </a:rPr>
+              <a:t>上一張最後一層之後，再接上偵測的那一層，就得到這張：YOLOX 在斑馬線那張照片上真的跑出來的結果。這種工作叫</a:t>
+            </a:r>
+            <a:r>
+              <a:rPr sz="1500" b="1" lang="zh-TW" dirty="0">
                 <a:solidFill>
                   <a:srgbClr val="000000"/>
                 </a:solidFill>
@@ -2003,7 +2003,7 @@
               <a:t>物件偵測</a:t>
             </a:r>
             <a:r>
-              <a:rPr sz="1600" lang="zh-TW" dirty="0">
+              <a:rPr sz="1500" lang="zh-TW" dirty="0">
                 <a:solidFill>
                   <a:srgbClr val="000000"/>
                 </a:solidFill>
@@ -2021,11 +2021,11 @@
                 <a:spcPts val="0"/>
               </a:spcBef>
               <a:spcAft>
-                <a:spcPts val="267"/>
+                <a:spcPts val="250"/>
               </a:spcAft>
             </a:pPr>
             <a:r>
-              <a:rPr sz="1600" b="1" lang="zh-TW" dirty="0">
+              <a:rPr sz="1500" b="1" lang="zh-TW" dirty="0">
                 <a:solidFill>
                   <a:srgbClr val="000000"/>
                 </a:solidFill>
@@ -2036,7 +2036,7 @@
               <a:t>第一，框。</a:t>
             </a:r>
             <a:r>
-              <a:rPr sz="1600" lang="zh-TW" dirty="0">
+              <a:rPr sz="1500" lang="zh-TW" dirty="0">
                 <a:solidFill>
                   <a:srgbClr val="000000"/>
                 </a:solidFill>
@@ -2047,7 +2047,7 @@
               <a:t>一個長方形，告訴你東西在照片的哪裡。注意，這是照片上的框，只知道在照片的左邊還是右邊、上面還是下面，</a:t>
             </a:r>
             <a:r>
-              <a:rPr sz="1600" b="1" lang="zh-TW" dirty="0">
+              <a:rPr sz="1500" b="1" lang="zh-TW" dirty="0">
                 <a:solidFill>
                   <a:srgbClr val="000000"/>
                 </a:solidFill>
@@ -2058,7 +2058,7 @@
               <a:t>不知道它離車子幾公尺</a:t>
             </a:r>
             <a:r>
-              <a:rPr sz="1600" lang="zh-TW" dirty="0">
+              <a:rPr sz="1500" lang="zh-TW" dirty="0">
                 <a:solidFill>
                   <a:srgbClr val="000000"/>
                 </a:solidFill>
@@ -2076,11 +2076,11 @@
                 <a:spcPts val="0"/>
               </a:spcBef>
               <a:spcAft>
-                <a:spcPts val="267"/>
+                <a:spcPts val="250"/>
               </a:spcAft>
             </a:pPr>
             <a:r>
-              <a:rPr sz="1600" b="1" lang="zh-TW" dirty="0">
+              <a:rPr sz="1500" b="1" lang="zh-TW" dirty="0">
                 <a:solidFill>
                   <a:srgbClr val="000000"/>
                 </a:solidFill>
@@ -2091,7 +2091,7 @@
               <a:t>第二，類別。</a:t>
             </a:r>
             <a:r>
-              <a:rPr sz="1600" lang="zh-TW" dirty="0">
+              <a:rPr sz="1500" lang="zh-TW" dirty="0">
                 <a:solidFill>
                   <a:srgbClr val="000000"/>
                 </a:solidFill>
@@ -2109,11 +2109,11 @@
                 <a:spcPts val="0"/>
               </a:spcBef>
               <a:spcAft>
-                <a:spcPts val="267"/>
+                <a:spcPts val="250"/>
               </a:spcAft>
             </a:pPr>
             <a:r>
-              <a:rPr sz="1600" b="1" lang="zh-TW" dirty="0">
+              <a:rPr sz="1500" b="1" lang="zh-TW" dirty="0">
                 <a:solidFill>
                   <a:srgbClr val="000000"/>
                 </a:solidFill>
@@ -2124,7 +2124,7 @@
               <a:t>第三，分數。</a:t>
             </a:r>
             <a:r>
-              <a:rPr sz="1600" lang="zh-TW" dirty="0">
+              <a:rPr sz="1500" lang="zh-TW" dirty="0">
                 <a:solidFill>
                   <a:srgbClr val="000000"/>
                 </a:solidFill>
@@ -2142,11 +2142,11 @@
                 <a:spcPts val="0"/>
               </a:spcBef>
               <a:spcAft>
-                <a:spcPts val="267"/>
+                <a:spcPts val="250"/>
               </a:spcAft>
             </a:pPr>
             <a:r>
-              <a:rPr sz="1600" lang="zh-TW" dirty="0">
+              <a:rPr sz="1500" lang="zh-TW" dirty="0">
                 <a:solidFill>
                   <a:srgbClr val="000000"/>
                 </a:solidFill>
@@ -2164,11 +2164,11 @@
                 <a:spcPts val="0"/>
               </a:spcBef>
               <a:spcAft>
-                <a:spcPts val="267"/>
+                <a:spcPts val="250"/>
               </a:spcAft>
             </a:pPr>
             <a:r>
-              <a:rPr sz="1600" lang="zh-TW" dirty="0">
+              <a:rPr sz="1500" lang="zh-TW" dirty="0">
                 <a:solidFill>
                   <a:srgbClr val="000000"/>
                 </a:solidFill>
@@ -2179,7 +2179,7 @@
               <a:t>有一個常見的誤會：</a:t>
             </a:r>
             <a:r>
-              <a:rPr sz="1600" b="1" lang="zh-TW" dirty="0">
+              <a:rPr sz="1500" b="1" lang="zh-TW" dirty="0">
                 <a:solidFill>
                   <a:srgbClr val="000000"/>
                 </a:solidFill>
@@ -2190,7 +2190,7 @@
               <a:t>0.91 不等於「百分之九十一一定對」。</a:t>
             </a:r>
             <a:r>
-              <a:rPr sz="1600" lang="zh-TW" dirty="0">
+              <a:rPr sz="1500" lang="zh-TW" dirty="0">
                 <a:solidFill>
                   <a:srgbClr val="000000"/>
                 </a:solidFill>
@@ -2201,7 +2201,7 @@
               <a:t>它比較像考試的時候，答案旁邊自己寫「我有幾分把握」，有人寫九分的也會錯。這個分數真正的用途，是拿來排序、拿來切一刀：低於某個分數的框就不要了。這一刀叫</a:t>
             </a:r>
             <a:r>
-              <a:rPr sz="1600" b="1" lang="zh-TW" dirty="0">
+              <a:rPr sz="1500" b="1" lang="zh-TW" dirty="0">
                 <a:solidFill>
                   <a:srgbClr val="000000"/>
                 </a:solidFill>
@@ -2212,7 +2212,7 @@
               <a:t>門檻</a:t>
             </a:r>
             <a:r>
-              <a:rPr sz="1600" lang="zh-TW" dirty="0">
+              <a:rPr sz="1500" lang="zh-TW" dirty="0">
                 <a:solidFill>
                   <a:srgbClr val="000000"/>
                 </a:solidFill>
@@ -8412,11 +8412,11 @@
                 <a:spcPts val="0"/>
               </a:spcBef>
               <a:spcAft>
-                <a:spcPts val="208"/>
+                <a:spcPts val="200"/>
               </a:spcAft>
             </a:pPr>
             <a:r>
-              <a:rPr sz="1250" b="1" lang="zh-TW" dirty="0">
+              <a:rPr sz="1200" b="1" lang="zh-TW" dirty="0">
                 <a:solidFill>
                   <a:srgbClr val="000000"/>
                 </a:solidFill>
@@ -8427,7 +8427,7 @@
               <a:t>這一張的目的：</a:t>
             </a:r>
             <a:r>
-              <a:rPr sz="1250" lang="zh-TW" dirty="0">
+              <a:rPr sz="1200" lang="zh-TW" dirty="0">
                 <a:solidFill>
                   <a:srgbClr val="000000"/>
                 </a:solidFill>
@@ -8445,11 +8445,11 @@
                 <a:spcPts val="0"/>
               </a:spcBef>
               <a:spcAft>
-                <a:spcPts val="208"/>
+                <a:spcPts val="200"/>
               </a:spcAft>
             </a:pPr>
             <a:r>
-              <a:rPr sz="1250" lang="zh-TW" dirty="0">
+              <a:rPr sz="1200" lang="zh-TW" dirty="0">
                 <a:solidFill>
                   <a:srgbClr val="000000"/>
                 </a:solidFill>
@@ -8460,7 +8460,7 @@
               <a:t>這張表要直著讀，一欄一種做法。但最重要的是先橫著讀</a:t>
             </a:r>
             <a:r>
-              <a:rPr sz="1250" b="1" lang="zh-TW" dirty="0">
+              <a:rPr sz="1200" b="1" lang="zh-TW" dirty="0">
                 <a:solidFill>
                   <a:srgbClr val="000000"/>
                 </a:solidFill>
@@ -8471,7 +8471,7 @@
               <a:t>第一列</a:t>
             </a:r>
             <a:r>
-              <a:rPr sz="1250" lang="zh-TW" dirty="0">
+              <a:rPr sz="1200" lang="zh-TW" dirty="0">
                 <a:solidFill>
                   <a:srgbClr val="000000"/>
                 </a:solidFill>
@@ -8489,11 +8489,11 @@
                 <a:spcPts val="0"/>
               </a:spcBef>
               <a:spcAft>
-                <a:spcPts val="208"/>
+                <a:spcPts val="200"/>
               </a:spcAft>
             </a:pPr>
             <a:r>
-              <a:rPr sz="1250" lang="zh-TW" dirty="0">
+              <a:rPr sz="1200" lang="zh-TW" dirty="0">
                 <a:solidFill>
                   <a:srgbClr val="000000"/>
                 </a:solidFill>
@@ -8504,7 +8504,7 @@
               <a:t>要認出一個東西，其實有兩個問題。第一個問題：</a:t>
             </a:r>
             <a:r>
-              <a:rPr sz="1250" b="1" lang="zh-TW" dirty="0">
+              <a:rPr sz="1200" b="1" lang="zh-TW" dirty="0">
                 <a:solidFill>
                   <a:srgbClr val="000000"/>
                 </a:solidFill>
@@ -8515,7 +8515,7 @@
               <a:t>看什麼</a:t>
             </a:r>
             <a:r>
-              <a:rPr sz="1250" lang="zh-TW" dirty="0">
+              <a:rPr sz="1200" lang="zh-TW" dirty="0">
                 <a:solidFill>
                   <a:srgbClr val="000000"/>
                 </a:solidFill>
@@ -8526,7 +8526,7 @@
               <a:t>？也就是要觀察照片的哪一種性質，專業的說法叫「</a:t>
             </a:r>
             <a:r>
-              <a:rPr sz="1250" b="1" lang="zh-TW" dirty="0">
+              <a:rPr sz="1200" b="1" lang="zh-TW" dirty="0">
                 <a:solidFill>
                   <a:srgbClr val="000000"/>
                 </a:solidFill>
@@ -8537,7 +8537,7 @@
               <a:t>特徵</a:t>
             </a:r>
             <a:r>
-              <a:rPr sz="1250" lang="zh-TW" dirty="0">
+              <a:rPr sz="1200" lang="zh-TW" dirty="0">
                 <a:solidFill>
                   <a:srgbClr val="000000"/>
                 </a:solidFill>
@@ -8548,7 +8548,7 @@
               <a:t>」。例如框是瘦高還是矮寬、顏色偏紅還是偏綠、邊緣是直的還是彎的。第二個問題：</a:t>
             </a:r>
             <a:r>
-              <a:rPr sz="1250" b="1" lang="zh-TW" dirty="0">
+              <a:rPr sz="1200" b="1" lang="zh-TW" dirty="0">
                 <a:solidFill>
                   <a:srgbClr val="000000"/>
                 </a:solidFill>
@@ -8559,7 +8559,7 @@
               <a:t>怎麼判斷</a:t>
             </a:r>
             <a:r>
-              <a:rPr sz="1250" lang="zh-TW" dirty="0">
+              <a:rPr sz="1200" lang="zh-TW" dirty="0">
                 <a:solidFill>
                   <a:srgbClr val="000000"/>
                 </a:solidFill>
@@ -8577,11 +8577,11 @@
                 <a:spcPts val="0"/>
               </a:spcBef>
               <a:spcAft>
-                <a:spcPts val="208"/>
+                <a:spcPts val="200"/>
               </a:spcAft>
             </a:pPr>
             <a:r>
-              <a:rPr sz="1250" b="1" lang="zh-TW" dirty="0">
+              <a:rPr sz="1200" b="1" lang="zh-TW" dirty="0">
                 <a:solidFill>
                   <a:srgbClr val="000000"/>
                 </a:solidFill>
@@ -8592,7 +8592,7 @@
               <a:t>寫規則</a:t>
             </a:r>
             <a:r>
-              <a:rPr sz="1250" lang="zh-TW" dirty="0">
+              <a:rPr sz="1200" lang="zh-TW" dirty="0">
                 <a:solidFill>
                   <a:srgbClr val="000000"/>
                 </a:solidFill>
@@ -8610,11 +8610,11 @@
                 <a:spcPts val="0"/>
               </a:spcBef>
               <a:spcAft>
-                <a:spcPts val="208"/>
+                <a:spcPts val="200"/>
               </a:spcAft>
             </a:pPr>
             <a:r>
-              <a:rPr sz="1250" b="1" lang="zh-TW" dirty="0">
+              <a:rPr sz="1200" b="1" lang="zh-TW" dirty="0">
                 <a:solidFill>
                   <a:srgbClr val="000000"/>
                 </a:solidFill>
@@ -8625,7 +8625,7 @@
               <a:t>傳統的機器學習</a:t>
             </a:r>
             <a:r>
-              <a:rPr sz="1250" lang="zh-TW" dirty="0">
+              <a:rPr sz="1200" lang="zh-TW" dirty="0">
                 <a:solidFill>
                   <a:srgbClr val="000000"/>
                 </a:solidFill>
@@ -8636,7 +8636,7 @@
               <a:t>：第一個問題「看什麼」還是</a:t>
             </a:r>
             <a:r>
-              <a:rPr sz="1250" b="1" lang="zh-TW" dirty="0">
+              <a:rPr sz="1200" b="1" lang="zh-TW" dirty="0">
                 <a:solidFill>
                   <a:srgbClr val="000000"/>
                 </a:solidFill>
@@ -8647,7 +8647,7 @@
               <a:t>人</a:t>
             </a:r>
             <a:r>
-              <a:rPr sz="1250" lang="zh-TW" dirty="0">
+              <a:rPr sz="1200" lang="zh-TW" dirty="0">
                 <a:solidFill>
                   <a:srgbClr val="000000"/>
                 </a:solidFill>
@@ -8658,7 +8658,7 @@
               <a:t>決定，第二個問題「怎麼判斷」交給</a:t>
             </a:r>
             <a:r>
-              <a:rPr sz="1250" b="1" lang="zh-TW" dirty="0">
+              <a:rPr sz="1200" b="1" lang="zh-TW" dirty="0">
                 <a:solidFill>
                   <a:srgbClr val="000000"/>
                 </a:solidFill>
@@ -8669,7 +8669,7 @@
               <a:t>電腦從例子學</a:t>
             </a:r>
             <a:r>
-              <a:rPr sz="1250" lang="zh-TW" dirty="0">
+              <a:rPr sz="1200" lang="zh-TW" dirty="0">
                 <a:solidFill>
                   <a:srgbClr val="000000"/>
                 </a:solidFill>
@@ -8687,11 +8687,11 @@
                 <a:spcPts val="0"/>
               </a:spcBef>
               <a:spcAft>
-                <a:spcPts val="208"/>
+                <a:spcPts val="200"/>
               </a:spcAft>
             </a:pPr>
             <a:r>
-              <a:rPr sz="1250" b="1" lang="zh-TW" dirty="0">
+              <a:rPr sz="1200" b="1" lang="zh-TW" dirty="0">
                 <a:solidFill>
                   <a:srgbClr val="000000"/>
                 </a:solidFill>
@@ -8702,7 +8702,7 @@
               <a:t>深度學習</a:t>
             </a:r>
             <a:r>
-              <a:rPr sz="1250" lang="zh-TW" dirty="0">
+              <a:rPr sz="1200" lang="zh-TW" dirty="0">
                 <a:solidFill>
                   <a:srgbClr val="000000"/>
                 </a:solidFill>
@@ -8713,7 +8713,7 @@
               <a:t>：連第一個問題「看什麼」都</a:t>
             </a:r>
             <a:r>
-              <a:rPr sz="1250" b="1" lang="zh-TW" dirty="0">
+              <a:rPr sz="1200" b="1" lang="zh-TW" dirty="0">
                 <a:solidFill>
                   <a:srgbClr val="000000"/>
                 </a:solidFill>
@@ -8724,18 +8724,40 @@
               <a:t>交給電腦</a:t>
             </a:r>
             <a:r>
-              <a:rPr sz="1250" lang="zh-TW" dirty="0">
-                <a:solidFill>
-                  <a:srgbClr val="000000"/>
-                </a:solidFill>
-                <a:latin typeface="Arial Unicode MS"/>
-                <a:ea typeface="Arial Unicode MS"/>
-                <a:cs typeface="Arial Unicode MS"/>
-              </a:rPr>
-              <a:t>。給它的就是原始的像素，四百多萬個數字，它自己從例子裡學出要看什麼。上一節用的 YOLOX，裡面大約有</a:t>
-            </a:r>
-            <a:r>
-              <a:rPr sz="1250" b="1" lang="zh-TW" dirty="0">
+              <a:rPr sz="1200" lang="zh-TW" dirty="0">
+                <a:solidFill>
+                  <a:srgbClr val="000000"/>
+                </a:solidFill>
+                <a:latin typeface="Arial Unicode MS"/>
+                <a:ea typeface="Arial Unicode MS"/>
+                <a:cs typeface="Arial Unicode MS"/>
+              </a:rPr>
+              <a:t>。給它的就是原始的像素，四百多萬個數字，它自己從例子裡學出要看什麼。這一節後面會一直用到一個深度學習的模型，叫 </a:t>
+            </a:r>
+            <a:r>
+              <a:rPr sz="1200" b="1" lang="zh-TW" dirty="0">
+                <a:solidFill>
+                  <a:srgbClr val="000000"/>
+                </a:solidFill>
+                <a:latin typeface="Arial Unicode MS"/>
+                <a:ea typeface="Arial Unicode MS"/>
+                <a:cs typeface="Arial Unicode MS"/>
+              </a:rPr>
+              <a:t>YOLOX</a:t>
+            </a:r>
+            <a:r>
+              <a:rPr sz="1200" lang="zh-TW" dirty="0">
+                <a:solidFill>
+                  <a:srgbClr val="000000"/>
+                </a:solidFill>
+                <a:latin typeface="Arial Unicode MS"/>
+                <a:ea typeface="Arial Unicode MS"/>
+                <a:cs typeface="Arial Unicode MS"/>
+              </a:rPr>
+              <a:t>。它是專門找物體的模型，2021 年由一家中國的 AI 公司（曠視，Megvii）公開，任何人都可以免費下載使用。我把它下載下來，在上週那份 nuScenes 資料的四百零四張前方照片上全部跑過一次，後面投影片上的框、分數和統計，都是它真的跑出來的。YOLOX 裡面大約有</a:t>
+            </a:r>
+            <a:r>
+              <a:rPr sz="1200" b="1" lang="zh-TW" dirty="0">
                 <a:solidFill>
                   <a:srgbClr val="000000"/>
                 </a:solidFill>
@@ -8746,7 +8768,7 @@
               <a:t>九百萬個數字</a:t>
             </a:r>
             <a:r>
-              <a:rPr sz="1250" lang="zh-TW" dirty="0">
+              <a:rPr sz="1200" lang="zh-TW" dirty="0">
                 <a:solidFill>
                   <a:srgbClr val="000000"/>
                 </a:solidFill>
@@ -8764,11 +8786,11 @@
                 <a:spcPts val="0"/>
               </a:spcBef>
               <a:spcAft>
-                <a:spcPts val="208"/>
+                <a:spcPts val="200"/>
               </a:spcAft>
             </a:pPr>
             <a:r>
-              <a:rPr sz="1250" lang="zh-TW" dirty="0">
+              <a:rPr sz="1200" lang="zh-TW" dirty="0">
                 <a:solidFill>
                   <a:srgbClr val="000000"/>
                 </a:solidFill>
@@ -8779,7 +8801,7 @@
               <a:t>所以三者的差別，一句話：</a:t>
             </a:r>
             <a:r>
-              <a:rPr sz="1250" b="1" lang="zh-TW" dirty="0">
+              <a:rPr sz="1200" b="1" lang="zh-TW" dirty="0">
                 <a:solidFill>
                   <a:srgbClr val="000000"/>
                 </a:solidFill>
@@ -8790,7 +8812,7 @@
               <a:t>寫規則，人決定看什麼也決定怎麼判斷；機器學習，人決定看什麼，電腦學怎麼判斷；深度學習，兩個都是電腦學。</a:t>
             </a:r>
             <a:r>
-              <a:rPr sz="1250" lang="zh-TW" dirty="0">
+              <a:rPr sz="1200" lang="zh-TW" dirty="0">
                 <a:solidFill>
                   <a:srgbClr val="000000"/>
                 </a:solidFill>
@@ -8808,11 +8830,11 @@
                 <a:spcPts val="0"/>
               </a:spcBef>
               <a:spcAft>
-                <a:spcPts val="208"/>
+                <a:spcPts val="200"/>
               </a:spcAft>
             </a:pPr>
             <a:r>
-              <a:rPr sz="1250" lang="zh-TW" dirty="0">
+              <a:rPr sz="1200" lang="zh-TW" dirty="0">
                 <a:solidFill>
                   <a:srgbClr val="000000"/>
                 </a:solidFill>

</xml_diff>

<commit_message>
Week 8 L1 slide 11: slower learning-rate animation (lr 0.3, slope line and step arrow for the first 8 steps)
Co-Authored-By: Claude Opus 5.5 <noreply@anthropic.com>
</commit_message>
<xml_diff>
--- a/第八週(10-29)/第八週_第1節_簡報.pptx
+++ b/第八週(10-29)/第八週_第1節_簡報.pptx
@@ -1341,7 +1341,51 @@
                 <a:ea typeface="Arial Unicode MS"/>
                 <a:cs typeface="Arial Unicode MS"/>
               </a:rPr>
-              <a:t>。谷底就是最好的門檻。中間那條淺綠色的帶，是分得對的範圍：汽車最高到 1.02，大人最低 1.25，門檻放在中間就全部分對。黃色的球是電腦目前的門檻，從 2.6 出發，每一次修改，就往下坡走「步伐乘以斜度」那麼遠。三格只差在步伐，也就是學習率。
+              <a:t>。谷底就是最好的門檻。中間那條淺綠色的帶，是分得對的範圍：汽車最高到 1.02，大人最低 1.25，門檻放在中間就全部分對。黃色的球是電腦目前的門檻，從 2.6 出發，每一次修改，就往下坡走「步伐乘以斜度」那麼遠。前八步會放慢：每一步跳之前，球腳下先出現一小段</a:t>
+            </a:r>
+            <a:r>
+              <a:rPr sz="850" b="1" lang="zh-TW" dirty="0">
+                <a:solidFill>
+                  <a:srgbClr val="000000"/>
+                </a:solidFill>
+                <a:latin typeface="Arial Unicode MS"/>
+                <a:ea typeface="Arial Unicode MS"/>
+                <a:cs typeface="Arial Unicode MS"/>
+              </a:rPr>
+              <a:t>黃色斜線</a:t>
+            </a:r>
+            <a:r>
+              <a:rPr sz="850" lang="zh-TW" dirty="0">
+                <a:solidFill>
+                  <a:srgbClr val="000000"/>
+                </a:solidFill>
+                <a:latin typeface="Arial Unicode MS"/>
+                <a:ea typeface="Arial Unicode MS"/>
+                <a:cs typeface="Arial Unicode MS"/>
+              </a:rPr>
+              <a:t>，那就是電腦算出來的斜度；下面再出現一個</a:t>
+            </a:r>
+            <a:r>
+              <a:rPr sz="850" b="1" lang="zh-TW" dirty="0">
+                <a:solidFill>
+                  <a:srgbClr val="000000"/>
+                </a:solidFill>
+                <a:latin typeface="Arial Unicode MS"/>
+                <a:ea typeface="Arial Unicode MS"/>
+                <a:cs typeface="Arial Unicode MS"/>
+              </a:rPr>
+              <a:t>箭頭</a:t>
+            </a:r>
+            <a:r>
+              <a:rPr sz="850" lang="zh-TW" dirty="0">
+                <a:solidFill>
+                  <a:srgbClr val="000000"/>
+                </a:solidFill>
+                <a:latin typeface="Arial Unicode MS"/>
+                <a:ea typeface="Arial Unicode MS"/>
+                <a:cs typeface="Arial Unicode MS"/>
+              </a:rPr>
+              <a:t>，標出這一步要跳多遠。三格只差在步伐，也就是學習率。
 </a:t>
             </a:r>
           </a:p>
@@ -1374,7 +1418,29 @@
                 <a:ea typeface="Arial Unicode MS"/>
                 <a:cs typeface="Arial Unicode MS"/>
               </a:rPr>
-              <a:t>：第一步就跳到 1.38，第三步落進淺綠帶，之後停在 1.17，全部分對。
+              <a:t>：第一步從 2.6 跳到 1.99，第二步 1.60，第三步 1.41，第四步 1.31……請看下面的箭頭，</a:t>
+            </a:r>
+            <a:r>
+              <a:rPr sz="850" b="1" lang="zh-TW" dirty="0">
+                <a:solidFill>
+                  <a:srgbClr val="000000"/>
+                </a:solidFill>
+                <a:latin typeface="Arial Unicode MS"/>
+                <a:ea typeface="Arial Unicode MS"/>
+                <a:cs typeface="Arial Unicode MS"/>
+              </a:rPr>
+              <a:t>一次比一次短</a:t>
+            </a:r>
+            <a:r>
+              <a:rPr sz="850" lang="zh-TW" dirty="0">
+                <a:solidFill>
+                  <a:srgbClr val="000000"/>
+                </a:solidFill>
+                <a:latin typeface="Arial Unicode MS"/>
+                <a:ea typeface="Arial Unicode MS"/>
+                <a:cs typeface="Arial Unicode MS"/>
+              </a:rPr>
+              <a:t>。因為愈靠近谷底，坡愈平，斜度愈小，「步伐乘以斜度」自然就愈小，球會自己放慢。第六步走進淺綠帶，最後停在 1.17，全部分對。
 </a:t>
             </a:r>
           </a:p>
@@ -12366,8 +12432,8 @@
         </p:nvSpPr>
         <p:spPr>
           <a:xfrm>
-            <a:off x="1280765" y="1371600"/>
-            <a:ext cx="6582471" cy="2633472"/>
+            <a:off x="1471793" y="1371600"/>
+            <a:ext cx="6200415" cy="2633472"/>
           </a:xfrm>
           <a:prstGeom prst="rect">
             <a:avLst/>
@@ -12399,8 +12465,8 @@
         </p:blipFill>
         <p:spPr>
           <a:xfrm>
-            <a:off x="1299053" y="1389888"/>
-            <a:ext cx="6545895" cy="2596896"/>
+            <a:off x="1490081" y="1389888"/>
+            <a:ext cx="6163839" cy="2596896"/>
           </a:xfrm>
           <a:prstGeom prst="rect">
             <a:avLst/>

</xml_diff>